<commit_message>
Add the project video, name the authors on the deck, label MAE correctly
writeup/video/ holds a silent three-minute walk through the project built
from the slide PDF with the narration as on-screen text, and the script
that renders it. The title slide names all four authors. The harness MAE
is the mean |score - truth| on the 1 to 5 scale times 100, so the slides,
report and Baxter summary now say so instead of "0 to 100 scale".
The deck builder follows the moved hrdexdb/videos path.

Co-Authored-By: Claude Fable 5.1 <noreply@anthropic.com>
</commit_message>
<xml_diff>
--- a/writeup/slides/tactile-flora.pptx
+++ b/writeup/slides/tactile-flora.pptx
@@ -3603,7 +3603,7 @@
       </p:sp>
       <p:sp>
         <p:nvSpPr>
-          <p:cNvPr id="4" name="text ['Oren Gershony and collaborators, Triton Droids / SDSC', '2026-10-24']"/>
+          <p:cNvPr id="4" name="text ['Oren Gershony, Aaryan Patel, Kenan Blair and Parth Trivedi  ·  Triton Droids, UC San Diego', '2026-10-24']"/>
           <p:cNvSpPr txBox="1"/>
           <p:nvPr/>
         </p:nvSpPr>
@@ -3631,7 +3631,7 @@
                 </a:solidFill>
                 <a:latin typeface="Calibri"/>
               </a:rPr>
-              <a:t>Oren Gershony and collaborators, Triton Droids / SDSC</a:t>
+              <a:t>Oren Gershony, Aaryan Patel, Kenan Blair and Parth Trivedi  ·  Triton Droids, UC San Diego</a:t>
             </a:r>
           </a:p>
           <a:p>
@@ -4921,7 +4921,7 @@
                 </a:solidFill>
                 <a:latin typeface="Calibri"/>
               </a:rPr>
-              <a:t>All 26 such clips are rendered as side-by-side videos in writeup/videos/; the 19 the video-only model wins are listed in writeup/comparison.md.</a:t>
+              <a:t>All 26 such clips are rendered as side-by-side videos in writeup/hrdexdb/videos/; the 19 the video-only model wins are listed in writeup/hrdexdb/README.md.</a:t>
             </a:r>
           </a:p>
         </p:txBody>
@@ -7875,7 +7875,7 @@
                 </a:solidFill>
                 <a:latin typeface="Calibri"/>
               </a:rPr>
-              <a:t>Rationale from the released model on rollout ep0000 (writeup/baxter-rollouts.md).</a:t>
+              <a:t>Rationale from the released model on rollout ep0000 (writeup/baxter-rollouts/README.md).</a:t>
             </a:r>
           </a:p>
         </p:txBody>
@@ -12189,14 +12189,14 @@
       </p:graphicFrame>
       <p:sp>
         <p:nvSpPr>
-          <p:cNvPr id="8" name="text MAE on dev (0 to 100"/>
+          <p:cNvPr id="8" name="text MAE on dev (mean |sc"/>
           <p:cNvSpPr txBox="1"/>
           <p:nvPr/>
         </p:nvSpPr>
         <p:spPr>
           <a:xfrm>
             <a:off x="8138160" y="3291840"/>
-            <a:ext cx="3566160" cy="731520"/>
+            <a:ext cx="3566160" cy="822960"/>
           </a:xfrm>
           <a:prstGeom prst="rect">
             <a:avLst/>
@@ -12217,7 +12217,7 @@
                 </a:solidFill>
                 <a:latin typeface="Calibri"/>
               </a:rPr>
-              <a:t>MAE on dev (0 to 100): 150 released, 71 video only, 53 tactile.</a:t>
+              <a:t>MAE on dev (mean |score − truth| on the 1 to 5 scale, times 100): 150 released, 71 video only, 53 tactile.</a:t>
             </a:r>
           </a:p>
         </p:txBody>
@@ -12918,7 +12918,7 @@
                 </a:solidFill>
                 <a:latin typeface="Calibri"/>
               </a:rPr>
-              <a:t>dev MAE 150 to 53 on the 0 to 100 scale</a:t>
+              <a:t>dev MAE 150 to 53 (mean absolute error on the 1 to 5 scale, times 100)</a:t>
             </a:r>
           </a:p>
           <a:p>
@@ -13178,7 +13178,7 @@
                           </a:solidFill>
                           <a:latin typeface="Calibri"/>
                         </a:rPr>
-                        <a:t>MAE</a:t>
+                        <a:t>MAE ×100</a:t>
                       </a:r>
                     </a:p>
                   </a:txBody>

</xml_diff>